<commit_message>
Update Beijing Air Pollution presentation
</commit_message>
<xml_diff>
--- a/Beijing Air Pollution.pptx
+++ b/Beijing Air Pollution.pptx
@@ -310,7 +310,7 @@
           <a:p>
             <a:fld id="{5BCAD085-E8A6-8845-BD4E-CB4CCA059FC4}" type="datetimeFigureOut">
               <a:rPr lang="en-US" smtClean="0"/>
-              <a:t>4/24/26</a:t>
+              <a:t>4/26/26</a:t>
             </a:fld>
             <a:endParaRPr lang="en-US"/>
           </a:p>
@@ -478,7 +478,7 @@
           <a:p>
             <a:fld id="{5BCAD085-E8A6-8845-BD4E-CB4CCA059FC4}" type="datetimeFigureOut">
               <a:rPr lang="en-US" smtClean="0"/>
-              <a:t>4/24/26</a:t>
+              <a:t>4/26/26</a:t>
             </a:fld>
             <a:endParaRPr lang="en-US"/>
           </a:p>
@@ -656,7 +656,7 @@
           <a:p>
             <a:fld id="{5BCAD085-E8A6-8845-BD4E-CB4CCA059FC4}" type="datetimeFigureOut">
               <a:rPr lang="en-US" smtClean="0"/>
-              <a:t>4/24/26</a:t>
+              <a:t>4/26/26</a:t>
             </a:fld>
             <a:endParaRPr lang="en-US"/>
           </a:p>
@@ -824,7 +824,7 @@
           <a:p>
             <a:fld id="{5BCAD085-E8A6-8845-BD4E-CB4CCA059FC4}" type="datetimeFigureOut">
               <a:rPr lang="en-US" smtClean="0"/>
-              <a:t>4/24/26</a:t>
+              <a:t>4/26/26</a:t>
             </a:fld>
             <a:endParaRPr lang="en-US"/>
           </a:p>
@@ -1069,7 +1069,7 @@
           <a:p>
             <a:fld id="{5BCAD085-E8A6-8845-BD4E-CB4CCA059FC4}" type="datetimeFigureOut">
               <a:rPr lang="en-US" smtClean="0"/>
-              <a:t>4/24/26</a:t>
+              <a:t>4/26/26</a:t>
             </a:fld>
             <a:endParaRPr lang="en-US"/>
           </a:p>
@@ -1354,7 +1354,7 @@
           <a:p>
             <a:fld id="{5BCAD085-E8A6-8845-BD4E-CB4CCA059FC4}" type="datetimeFigureOut">
               <a:rPr lang="en-US" smtClean="0"/>
-              <a:t>4/24/26</a:t>
+              <a:t>4/26/26</a:t>
             </a:fld>
             <a:endParaRPr lang="en-US"/>
           </a:p>
@@ -1773,7 +1773,7 @@
           <a:p>
             <a:fld id="{5BCAD085-E8A6-8845-BD4E-CB4CCA059FC4}" type="datetimeFigureOut">
               <a:rPr lang="en-US" smtClean="0"/>
-              <a:t>4/24/26</a:t>
+              <a:t>4/26/26</a:t>
             </a:fld>
             <a:endParaRPr lang="en-US"/>
           </a:p>
@@ -1890,7 +1890,7 @@
           <a:p>
             <a:fld id="{5BCAD085-E8A6-8845-BD4E-CB4CCA059FC4}" type="datetimeFigureOut">
               <a:rPr lang="en-US" smtClean="0"/>
-              <a:t>4/24/26</a:t>
+              <a:t>4/26/26</a:t>
             </a:fld>
             <a:endParaRPr lang="en-US"/>
           </a:p>
@@ -1985,7 +1985,7 @@
           <a:p>
             <a:fld id="{5BCAD085-E8A6-8845-BD4E-CB4CCA059FC4}" type="datetimeFigureOut">
               <a:rPr lang="en-US" smtClean="0"/>
-              <a:t>4/24/26</a:t>
+              <a:t>4/26/26</a:t>
             </a:fld>
             <a:endParaRPr lang="en-US"/>
           </a:p>
@@ -2260,7 +2260,7 @@
           <a:p>
             <a:fld id="{5BCAD085-E8A6-8845-BD4E-CB4CCA059FC4}" type="datetimeFigureOut">
               <a:rPr lang="en-US" smtClean="0"/>
-              <a:t>4/24/26</a:t>
+              <a:t>4/26/26</a:t>
             </a:fld>
             <a:endParaRPr lang="en-US"/>
           </a:p>
@@ -2512,7 +2512,7 @@
           <a:p>
             <a:fld id="{5BCAD085-E8A6-8845-BD4E-CB4CCA059FC4}" type="datetimeFigureOut">
               <a:rPr lang="en-US" smtClean="0"/>
-              <a:t>4/24/26</a:t>
+              <a:t>4/26/26</a:t>
             </a:fld>
             <a:endParaRPr lang="en-US"/>
           </a:p>
@@ -2723,7 +2723,7 @@
           <a:p>
             <a:fld id="{5BCAD085-E8A6-8845-BD4E-CB4CCA059FC4}" type="datetimeFigureOut">
               <a:rPr lang="en-US" smtClean="0"/>
-              <a:t>4/24/26</a:t>
+              <a:t>4/26/26</a:t>
             </a:fld>
             <a:endParaRPr lang="en-US"/>
           </a:p>
@@ -3265,7 +3265,7 @@
         <p:spPr>
           <a:xfrm>
             <a:off x="685800" y="2011680"/>
-            <a:ext cx="5120640" cy="3474720"/>
+            <a:ext cx="6150979" cy="730969"/>
           </a:xfrm>
           <a:prstGeom prst="rect">
             <a:avLst/>
@@ -3289,7 +3289,8 @@
               </a:defRPr>
             </a:pPr>
             <a:r>
-              <a:t>A polished, chart-rich deck rebuilt from README content.</a:t>
+              <a:rPr dirty="0"/>
+              <a:t>Includes descriptive analytics, station comparison, and correlations.</a:t>
             </a:r>
           </a:p>
           <a:p>
@@ -3304,21 +3305,7 @@
               </a:defRPr>
             </a:pPr>
             <a:r>
-              <a:t>Includes descriptive analytics, station comparison, and correlations.</a:t>
-            </a:r>
-          </a:p>
-          <a:p>
-            <a:pPr>
-              <a:spcAft>
-                <a:spcPts val="900"/>
-              </a:spcAft>
-              <a:defRPr sz="1700">
-                <a:solidFill>
-                  <a:srgbClr val="28303F"/>
-                </a:solidFill>
-              </a:defRPr>
-            </a:pPr>
-            <a:r>
+              <a:rPr dirty="0"/>
               <a:t>Enhanced with custom thematic visuals for stronger storytelling.</a:t>
             </a:r>
           </a:p>

</xml_diff>

<commit_message>
Re-submit Beijing Air Pollution.pptx
</commit_message>
<xml_diff>
--- a/Beijing Air Pollution.pptx
+++ b/Beijing Air Pollution.pptx
@@ -3230,7 +3230,7 @@
         <p:spPr>
           <a:xfrm>
             <a:off x="566928" y="1207008"/>
-            <a:ext cx="10607040" cy="731520"/>
+            <a:ext cx="2399888" cy="338554"/>
           </a:xfrm>
           <a:prstGeom prst="rect">
             <a:avLst/>
@@ -3251,7 +3251,11 @@
               </a:defRPr>
             </a:pPr>
             <a:r>
-              <a:t>Visual &amp; English Presentation | Data + Storytelling</a:t>
+              <a:t>Visual | </a:t>
+            </a:r>
+            <a:r>
+              <a:rPr dirty="0"/>
+              <a:t>Data + Storytelling</a:t>
             </a:r>
           </a:p>
         </p:txBody>

</xml_diff>